<commit_message>
docs(deck): add the challenges we solved to the last slide
The problem statement asks the presentation to cover architecture,
challenges and results; slide 7 now lists the look-ahead leak, date-only
timestamps, commentary-triggered stress tests and over-merged story
clusters next to the limitations and next steps.
</commit_message>
<xml_diff>
--- a/docs/presentation.pptx
+++ b/docs/presentation.pptx
@@ -928,7 +928,7 @@
           <a:lstStyle/>
           <a:p>
             <a:r>
-              <a:t>The main limitation is timing: most historical headlines carry a date only, so the backtest has to wait a full day, which is why no trading edge shows. The next step is intraday feeds. I would also add more languages, a production message bus and a full revaluation library.</a:t>
+              <a:t>The hardest problems were about trust, not models. An early backtest looked brilliant until I found it used news before it was published; with strict timing the edge disappears, and I report that. Most headlines carry only a date, so they count only after the day ends. And the stress trigger first fired on questions and opinion pieces, so it now runs only on reported, adverse events. Next: intraday feeds, more languages, a production message bus and a full revaluation library.</a:t>
             </a:r>
           </a:p>
         </p:txBody>
@@ -7328,7 +7328,7 @@
                 </a:solidFill>
                 <a:latin typeface="Calibri"/>
               </a:rPr>
-              <a:t>07  ·  LIMITATIONS &amp; NEXT STEPS</a:t>
+              <a:t>07  ·  CHALLENGES, LIMITATIONS &amp; NEXT STEPS</a:t>
             </a:r>
           </a:p>
         </p:txBody>
@@ -7377,7 +7377,7 @@
         <p:spPr>
           <a:xfrm>
             <a:off x="548640" y="777240"/>
-            <a:ext cx="10972800" cy="731520"/>
+            <a:ext cx="11155680" cy="731520"/>
           </a:xfrm>
           <a:prstGeom prst="rect">
             <a:avLst/>
@@ -7392,13 +7392,13 @@
           <a:p>
             <a:pPr algn="l"/>
             <a:r>
-              <a:rPr sz="3400" b="1" i="0">
+              <a:rPr sz="3200" b="1" i="0">
                 <a:solidFill>
                   <a:srgbClr val="FFFFFF"/>
                 </a:solidFill>
                 <a:latin typeface="Calibri"/>
               </a:rPr>
-              <a:t>What we would build next</a:t>
+              <a:t>What was hard, what is missing, what comes next</a:t>
             </a:r>
           </a:p>
         </p:txBody>
@@ -7411,8 +7411,8 @@
         </p:nvSpPr>
         <p:spPr>
           <a:xfrm>
-            <a:off x="548640" y="1783080"/>
-            <a:ext cx="5120640" cy="2926080"/>
+            <a:off x="548640" y="1737360"/>
+            <a:ext cx="3520440" cy="3200400"/>
           </a:xfrm>
           <a:prstGeom prst="rect">
             <a:avLst/>
@@ -7431,13 +7431,13 @@
               </a:spcAft>
             </a:pPr>
             <a:r>
-              <a:rPr sz="1900" b="1" i="0">
+              <a:rPr sz="1800" b="1" i="0">
                 <a:solidFill>
                   <a:srgbClr val="F2A541"/>
                 </a:solidFill>
                 <a:latin typeface="Calibri"/>
               </a:rPr>
-              <a:t>Limitations</a:t>
+              <a:t>Challenges we solved</a:t>
             </a:r>
           </a:p>
           <a:p>
@@ -7447,13 +7447,13 @@
               </a:spcAft>
             </a:pPr>
             <a:r>
-              <a:rPr sz="1600" b="0" i="0">
+              <a:rPr sz="1400" b="0" i="0">
                 <a:solidFill>
                   <a:srgbClr val="C9D3E0"/>
                 </a:solidFill>
                 <a:latin typeface="Calibri"/>
               </a:rPr>
-              <a:t>97% of the 61,399 archive headlines carry dates, not times</a:t>
+              <a:t>A backtest information ratio of 3.7 was a look-ahead leak: traced and fixed</a:t>
             </a:r>
           </a:p>
           <a:p>
@@ -7463,13 +7463,13 @@
               </a:spcAft>
             </a:pPr>
             <a:r>
-              <a:rPr sz="1600" b="0" i="0">
+              <a:rPr sz="1400" b="0" i="0">
                 <a:solidFill>
                   <a:srgbClr val="C9D3E0"/>
                 </a:solidFill>
                 <a:latin typeface="Calibri"/>
               </a:rPr>
-              <a:t>Mega-cap universe of 16 names; two years of history</a:t>
+              <a:t>97% of 61,399 headlines carry a date, not a time: used only after the day ends</a:t>
             </a:r>
           </a:p>
           <a:p>
@@ -7479,13 +7479,13 @@
               </a:spcAft>
             </a:pPr>
             <a:r>
-              <a:rPr sz="1600" b="0" i="0">
+              <a:rPr sz="1400" b="0" i="0">
                 <a:solidFill>
                   <a:srgbClr val="C9D3E0"/>
                 </a:solidFill>
                 <a:latin typeface="Calibri"/>
               </a:rPr>
-              <a:t>Gold labels from a single annotator</a:t>
+              <a:t>Questions and opinion pieces fired stress tests: now filtered (29 skipped in the replay)</a:t>
             </a:r>
           </a:p>
           <a:p>
@@ -7495,13 +7495,13 @@
               </a:spcAft>
             </a:pPr>
             <a:r>
-              <a:rPr sz="1600" b="0" i="0">
+              <a:rPr sz="1400" b="0" i="0">
                 <a:solidFill>
                   <a:srgbClr val="C9D3E0"/>
                 </a:solidFill>
                 <a:latin typeface="Calibri"/>
               </a:rPr>
-              <a:t>Sensitivity-based revaluation; simplified CET1 proxy</a:t>
+              <a:t>Story clusters swallowed unrelated news: now anchored on the first report</a:t>
             </a:r>
           </a:p>
         </p:txBody>
@@ -7514,8 +7514,8 @@
         </p:nvSpPr>
         <p:spPr>
           <a:xfrm>
-            <a:off x="6309360" y="1783080"/>
-            <a:ext cx="5303520" cy="2926080"/>
+            <a:off x="4343400" y="1737360"/>
+            <a:ext cx="3520440" cy="3200400"/>
           </a:xfrm>
           <a:prstGeom prst="rect">
             <a:avLst/>
@@ -7534,13 +7534,13 @@
               </a:spcAft>
             </a:pPr>
             <a:r>
-              <a:rPr sz="1900" b="1" i="0">
+              <a:rPr sz="1800" b="1" i="0">
                 <a:solidFill>
                   <a:srgbClr val="F2A541"/>
                 </a:solidFill>
                 <a:latin typeface="Calibri"/>
               </a:rPr>
-              <a:t>Next steps</a:t>
+              <a:t>Limitations</a:t>
             </a:r>
           </a:p>
           <a:p>
@@ -7550,13 +7550,13 @@
               </a:spcAft>
             </a:pPr>
             <a:r>
-              <a:rPr sz="1600" b="0" i="0">
+              <a:rPr sz="1400" b="0" i="0">
                 <a:solidFill>
                   <a:srgbClr val="C9D3E0"/>
                 </a:solidFill>
                 <a:latin typeface="Calibri"/>
               </a:rPr>
-              <a:t>Intraday timestamped feeds to test fast reactions</a:t>
+              <a:t>Day-level history, so fast intraday reactions are untested</a:t>
             </a:r>
           </a:p>
           <a:p>
@@ -7566,13 +7566,13 @@
               </a:spcAft>
             </a:pPr>
             <a:r>
-              <a:rPr sz="1600" b="0" i="0">
+              <a:rPr sz="1400" b="0" i="0">
                 <a:solidFill>
                   <a:srgbClr val="C9D3E0"/>
                 </a:solidFill>
                 <a:latin typeface="Calibri"/>
               </a:rPr>
-              <a:t>Multilingual sources and target-aware sentiment</a:t>
+              <a:t>16 mega-cap names and two years of data</a:t>
             </a:r>
           </a:p>
           <a:p>
@@ -7582,13 +7582,13 @@
               </a:spcAft>
             </a:pPr>
             <a:r>
-              <a:rPr sz="1600" b="0" i="0">
+              <a:rPr sz="1400" b="0" i="0">
                 <a:solidFill>
                   <a:srgbClr val="C9D3E0"/>
                 </a:solidFill>
                 <a:latin typeface="Calibri"/>
               </a:rPr>
-              <a:t>Kafka bus, feature store, model registry</a:t>
+              <a:t>Gold labels from one annotator (AI-proposed)</a:t>
             </a:r>
           </a:p>
           <a:p>
@@ -7598,12 +7598,115 @@
               </a:spcAft>
             </a:pPr>
             <a:r>
-              <a:rPr sz="1600" b="0" i="0">
+              <a:rPr sz="1400" b="0" i="0">
                 <a:solidFill>
                   <a:srgbClr val="C9D3E0"/>
                 </a:solidFill>
                 <a:latin typeface="Calibri"/>
               </a:rPr>
+              <a:t>Sensitivity-based revaluation; simplified CET1 proxy</a:t>
+            </a:r>
+          </a:p>
+        </p:txBody>
+      </p:sp>
+      <p:sp>
+        <p:nvSpPr>
+          <p:cNvPr id="7" name="text"/>
+          <p:cNvSpPr txBox="1"/>
+          <p:nvPr/>
+        </p:nvSpPr>
+        <p:spPr>
+          <a:xfrm>
+            <a:off x="8138160" y="1737360"/>
+            <a:ext cx="3520440" cy="3200400"/>
+          </a:xfrm>
+          <a:prstGeom prst="rect">
+            <a:avLst/>
+          </a:prstGeom>
+          <a:noFill/>
+        </p:spPr>
+        <p:txBody>
+          <a:bodyPr wrap="square" lIns="0" rIns="0" tIns="0" bIns="0" anchor="t">
+            <a:spAutoFit/>
+          </a:bodyPr>
+          <a:lstStyle/>
+          <a:p>
+            <a:pPr algn="l">
+              <a:spcAft>
+                <a:spcPts val="800"/>
+              </a:spcAft>
+            </a:pPr>
+            <a:r>
+              <a:rPr sz="1800" b="1" i="0">
+                <a:solidFill>
+                  <a:srgbClr val="F2A541"/>
+                </a:solidFill>
+                <a:latin typeface="Calibri"/>
+              </a:rPr>
+              <a:t>Next steps</a:t>
+            </a:r>
+          </a:p>
+          <a:p>
+            <a:pPr algn="l">
+              <a:spcAft>
+                <a:spcPts val="800"/>
+              </a:spcAft>
+            </a:pPr>
+            <a:r>
+              <a:rPr sz="1400" b="0" i="0">
+                <a:solidFill>
+                  <a:srgbClr val="C9D3E0"/>
+                </a:solidFill>
+                <a:latin typeface="Calibri"/>
+              </a:rPr>
+              <a:t>Intraday timestamped feeds to test fast reactions</a:t>
+            </a:r>
+          </a:p>
+          <a:p>
+            <a:pPr algn="l">
+              <a:spcAft>
+                <a:spcPts val="800"/>
+              </a:spcAft>
+            </a:pPr>
+            <a:r>
+              <a:rPr sz="1400" b="0" i="0">
+                <a:solidFill>
+                  <a:srgbClr val="C9D3E0"/>
+                </a:solidFill>
+                <a:latin typeface="Calibri"/>
+              </a:rPr>
+              <a:t>Multilingual sources and target-aware sentiment</a:t>
+            </a:r>
+          </a:p>
+          <a:p>
+            <a:pPr algn="l">
+              <a:spcAft>
+                <a:spcPts val="800"/>
+              </a:spcAft>
+            </a:pPr>
+            <a:r>
+              <a:rPr sz="1400" b="0" i="0">
+                <a:solidFill>
+                  <a:srgbClr val="C9D3E0"/>
+                </a:solidFill>
+                <a:latin typeface="Calibri"/>
+              </a:rPr>
+              <a:t>Kafka bus, feature store, model registry</a:t>
+            </a:r>
+          </a:p>
+          <a:p>
+            <a:pPr algn="l">
+              <a:spcAft>
+                <a:spcPts val="800"/>
+              </a:spcAft>
+            </a:pPr>
+            <a:r>
+              <a:rPr sz="1400" b="0" i="0">
+                <a:solidFill>
+                  <a:srgbClr val="C9D3E0"/>
+                </a:solidFill>
+                <a:latin typeface="Calibri"/>
+              </a:rPr>
               <a:t>Full revaluation library and regulatory scenarios</a:t>
             </a:r>
           </a:p>
@@ -7611,14 +7714,14 @@
       </p:sp>
       <p:sp>
         <p:nvSpPr>
-          <p:cNvPr id="7" name="pulse"/>
+          <p:cNvPr id="8" name="pulse"/>
           <p:cNvSpPr/>
           <p:nvPr/>
         </p:nvSpPr>
         <p:spPr>
           <a:xfrm>
-            <a:off x="548640" y="5106924"/>
-            <a:ext cx="11064240" cy="576072"/>
+            <a:off x="548640" y="5150357"/>
+            <a:ext cx="11064240" cy="534924"/>
           </a:xfrm>
           <a:custGeom>
             <a:avLst/>
@@ -7627,42 +7730,42 @@
             <a:cxnLst/>
             <a:rect l="l" t="t" r="r" b="b"/>
             <a:pathLst>
-              <a:path w="11064240" h="576072">
+              <a:path w="11064240" h="534924">
                 <a:moveTo>
-                  <a:pt x="0" y="288035"/>
+                  <a:pt x="0" y="267463"/>
                 </a:moveTo>
                 <a:lnTo>
-                  <a:pt x="3319271" y="288035"/>
+                  <a:pt x="3319271" y="267463"/>
                 </a:lnTo>
                 <a:lnTo>
-                  <a:pt x="3983126" y="192024"/>
+                  <a:pt x="3983126" y="178309"/>
                 </a:lnTo>
                 <a:lnTo>
-                  <a:pt x="4646980" y="288035"/>
+                  <a:pt x="4646980" y="267463"/>
                 </a:lnTo>
                 <a:lnTo>
-                  <a:pt x="5310835" y="288035"/>
+                  <a:pt x="5310835" y="267463"/>
                 </a:lnTo>
                 <a:lnTo>
                   <a:pt x="5753404" y="0"/>
                 </a:lnTo>
                 <a:lnTo>
-                  <a:pt x="6306616" y="576072"/>
+                  <a:pt x="6306616" y="534924"/>
                 </a:lnTo>
                 <a:lnTo>
-                  <a:pt x="6859828" y="288035"/>
+                  <a:pt x="6859828" y="267463"/>
                 </a:lnTo>
                 <a:lnTo>
-                  <a:pt x="7744967" y="288035"/>
+                  <a:pt x="7744967" y="267463"/>
                 </a:lnTo>
                 <a:lnTo>
-                  <a:pt x="8187537" y="211226"/>
+                  <a:pt x="8187537" y="196139"/>
                 </a:lnTo>
                 <a:lnTo>
-                  <a:pt x="8630107" y="288035"/>
+                  <a:pt x="8630107" y="267463"/>
                 </a:lnTo>
                 <a:lnTo>
-                  <a:pt x="11064240" y="288035"/>
+                  <a:pt x="11064240" y="267463"/>
                 </a:lnTo>
               </a:path>
             </a:pathLst>
@@ -7698,7 +7801,7 @@
       </p:sp>
       <p:sp>
         <p:nvSpPr>
-          <p:cNvPr id="8" name="text"/>
+          <p:cNvPr id="9" name="text"/>
           <p:cNvSpPr txBox="1"/>
           <p:nvPr/>
         </p:nvSpPr>

</xml_diff>

<commit_message>
docs: say that the AI-proposed gold labels were reviewed by the author
</commit_message>
<xml_diff>
--- a/docs/presentation.pptx
+++ b/docs/presentation.pptx
@@ -6181,7 +6181,7 @@
                 </a:solidFill>
                 <a:latin typeface="Calibri"/>
               </a:rPr>
-              <a:t>Lite tier without torch, offline replay demo, 110 tests, CI on Python 3.11</a:t>
+              <a:t>Lite tier without torch, offline replay demo, 111 tests, CI on Python 3.11</a:t>
             </a:r>
           </a:p>
         </p:txBody>
@@ -7588,7 +7588,7 @@
                 </a:solidFill>
                 <a:latin typeface="Calibri"/>
               </a:rPr>
-              <a:t>Gold labels from one annotator (AI-proposed)</a:t>
+              <a:t>Gold labels from one annotator (AI-proposed, author-reviewed)</a:t>
             </a:r>
           </a:p>
           <a:p>

</xml_diff>

<commit_message>
docs: final metrics, README results, screenshots and deck
Adds the two-year trigger test, the red-alert result and the triage funnel
to metrics.json and the README; screenshots show the alert levels and the
portfolio summary; the deck gets the new slide 5 and a readable slide 6.
</commit_message>
<xml_diff>
--- a/docs/presentation.pptx
+++ b/docs/presentation.pptx
@@ -788,7 +788,7 @@
           <a:lstStyle/>
           <a:p>
             <a:r>
-              <a:t>Each number compares RiskPulse with a naive approach on data the models never saw. Sentiment and event classification beat their baselines; the impact score lines up with market-wide moves better than sentiment alone, though both correlations are modest; and event-aware stress tests avoid the sign errors of a static shock. I also report what did not work: no reliable trading edge once timing is strict.</a:t>
+              <a:t>Each number compares RiskPulse with a naive approach on data the models never saw. Sentiment and event classification beat their baselines; out of sample, days with a red alert moved the S&amp;P 500 about a fifth more than other days, while simply picking the busiest news days did worse than chance; and event-aware stress tests avoid the sign errors of a static shock. I also report what did not work: no reliable trading edge once timing is strict.</a:t>
             </a:r>
           </a:p>
         </p:txBody>
@@ -6181,7 +6181,7 @@
                 </a:solidFill>
                 <a:latin typeface="Calibri"/>
               </a:rPr>
-              <a:t>Lite tier without torch, offline replay demo, 111 tests, CI on Python 3.11</a:t>
+              <a:t>Lite tier without torch, offline replay demo, 114 tests, CI on Python 3.11</a:t>
             </a:r>
           </a:p>
         </p:txBody>
@@ -6505,7 +6505,7 @@
                 </a:solidFill>
                 <a:latin typeface="Calibri"/>
               </a:rPr>
-              <a:t>0.09</a:t>
+              <a:t>1.21×</a:t>
             </a:r>
             <a:r>
               <a:rPr sz="1600" b="0" i="0">
@@ -6514,7 +6514,7 @@
                 </a:solidFill>
                 <a:latin typeface="Calibri"/>
               </a:rPr>
-              <a:t>  vs 0.03</a:t>
+              <a:t>  vs 0.85×</a:t>
             </a:r>
           </a:p>
         </p:txBody>
@@ -6549,7 +6549,7 @@
                 </a:solidFill>
                 <a:latin typeface="Calibri"/>
               </a:rPr>
-              <a:t>impact vs S&amp;P 500 moves, Spearman (naive: |sentiment|)</a:t>
+              <a:t>S&amp;P 500 move on red-alert days, out of sample (naive: busiest news days)</a:t>
             </a:r>
           </a:p>
         </p:txBody>
@@ -6649,8 +6649,8 @@
         </p:blipFill>
         <p:spPr>
           <a:xfrm>
-            <a:off x="5257800" y="1600200"/>
-            <a:ext cx="6355080" cy="3459988"/>
+            <a:off x="5486400" y="1554480"/>
+            <a:ext cx="5897880" cy="3211068"/>
           </a:xfrm>
           <a:prstGeom prst="rect">
             <a:avLst/>
@@ -6665,8 +6665,8 @@
         </p:nvSpPr>
         <p:spPr>
           <a:xfrm>
-            <a:off x="5257800" y="5257800"/>
-            <a:ext cx="6355080" cy="1097280"/>
+            <a:off x="5257800" y="4846320"/>
+            <a:ext cx="6355080" cy="1463040"/>
           </a:xfrm>
           <a:prstGeom prst="rect">
             <a:avLst/>
@@ -6685,22 +6685,22 @@
               </a:spcAft>
             </a:pPr>
             <a:r>
-              <a:rPr sz="1300" b="1" i="0">
+              <a:rPr sz="1250" b="1" i="0">
                 <a:solidFill>
                   <a:srgbClr val="1B2430"/>
                 </a:solidFill>
                 <a:latin typeface="Calibri"/>
               </a:rPr>
-              <a:t>Headline to stress-test result: </a:t>
-            </a:r>
-            <a:r>
-              <a:rPr sz="1300" b="0" i="0">
+              <a:t>Headline to stress result: </a:t>
+            </a:r>
+            <a:r>
+              <a:rPr sz="1250" b="0" i="0">
                 <a:solidFill>
                   <a:srgbClr val="5B6573"/>
                 </a:solidFill>
                 <a:latin typeface="Calibri"/>
               </a:rPr>
-              <a:t>0.2 s on a laptop CPU, vs an overnight batch run (assumed ~24 h).</a:t>
+              <a:t>0.2 s on a laptop CPU, vs an overnight batch run (assumed).</a:t>
             </a:r>
           </a:p>
           <a:p>
@@ -6710,22 +6710,47 @@
               </a:spcAft>
             </a:pPr>
             <a:r>
-              <a:rPr sz="1300" b="1" i="0">
+              <a:rPr sz="1250" b="1" i="0">
                 <a:solidFill>
                   <a:srgbClr val="1B2430"/>
                 </a:solidFill>
                 <a:latin typeface="Calibri"/>
               </a:rPr>
+              <a:t>Triage: </a:t>
+            </a:r>
+            <a:r>
+              <a:rPr sz="1250" b="0" i="0">
+                <a:solidFill>
+                  <a:srgbClr val="5B6573"/>
+                </a:solidFill>
+                <a:latin typeface="Calibri"/>
+              </a:rPr>
+              <a:t>~84 headlines a day become 1.5 stress tests; the trigger rules cut 70% of high-impact alerts.</a:t>
+            </a:r>
+          </a:p>
+          <a:p>
+            <a:pPr algn="l">
+              <a:spcAft>
+                <a:spcPts val="800"/>
+              </a:spcAft>
+            </a:pPr>
+            <a:r>
+              <a:rPr sz="1250" b="1" i="0">
+                <a:solidFill>
+                  <a:srgbClr val="1B2430"/>
+                </a:solidFill>
+                <a:latin typeface="Calibri"/>
+              </a:rPr>
               <a:t>Honest result: </a:t>
             </a:r>
             <a:r>
-              <a:rPr sz="1300" b="0" i="0">
+              <a:rPr sz="1250" b="0" i="0">
                 <a:solidFill>
                   <a:srgbClr val="5B6573"/>
                 </a:solidFill>
                 <a:latin typeface="Calibri"/>
               </a:rPr>
-              <a:t>with strict timing, sentiment tilts show no next-day edge (IC -0.004); a first backtest showing IR 3.7 was a look-ahead leak we traced and fixed.</a:t>
+              <a:t>with strict timing, sentiment tilts show no next-day edge (IC -0.004); an early IR of 3.7 was a look-ahead leak we traced and fixed.</a:t>
             </a:r>
           </a:p>
         </p:txBody>
@@ -6863,29 +6888,24 @@
       </p:sp>
       <p:sp>
         <p:nvSpPr>
-          <p:cNvPr id="5" name="screenshot-frame"/>
+          <p:cNvPr id="5" name="impact1-dot"/>
           <p:cNvSpPr/>
           <p:nvPr/>
         </p:nvSpPr>
         <p:spPr>
           <a:xfrm>
-            <a:off x="5989320" y="1600200"/>
-            <a:ext cx="5669280" cy="4480560"/>
-          </a:xfrm>
-          <a:prstGeom prst="roundRect">
-            <a:avLst>
-              <a:gd name="adj" fmla="val 6000"/>
-            </a:avLst>
+            <a:off x="548640" y="1645920"/>
+            <a:ext cx="347472" cy="347472"/>
+          </a:xfrm>
+          <a:prstGeom prst="ellipse">
+            <a:avLst/>
           </a:prstGeom>
           <a:solidFill>
-            <a:srgbClr val="F3F6FA"/>
+            <a:srgbClr val="E34948"/>
           </a:solidFill>
-          <a:ln w="12700">
-            <a:solidFill>
-              <a:srgbClr val="D5DBE3"/>
-            </a:solidFill>
+          <a:ln>
+            <a:noFill/>
           </a:ln>
-          <a:effectLst/>
         </p:spPr>
         <p:style>
           <a:lnRef idx="1">
@@ -6909,46 +6929,92 @@
           </a:p>
         </p:txBody>
       </p:sp>
-      <p:pic>
-        <p:nvPicPr>
-          <p:cNvPr id="6" name="dashboard-module-b" descr="dashboard_3_module_B.png"/>
-          <p:cNvPicPr>
-            <a:picLocks noChangeAspect="1"/>
-          </p:cNvPicPr>
-          <p:nvPr/>
-        </p:nvPicPr>
-        <p:blipFill>
-          <a:blip r:embed="rId2"/>
-          <a:stretch>
-            <a:fillRect/>
-          </a:stretch>
-        </p:blipFill>
-        <p:spPr>
-          <a:xfrm>
-            <a:off x="6126480" y="1737360"/>
-            <a:ext cx="5394960" cy="3371850"/>
+      <p:sp>
+        <p:nvSpPr>
+          <p:cNvPr id="6" name="text"/>
+          <p:cNvSpPr txBox="1"/>
+          <p:nvPr/>
+        </p:nvSpPr>
+        <p:spPr>
+          <a:xfrm>
+            <a:off x="1051560" y="1627632"/>
+            <a:ext cx="3108960" cy="411480"/>
           </a:xfrm>
           <a:prstGeom prst="rect">
             <a:avLst/>
           </a:prstGeom>
-        </p:spPr>
-      </p:pic>
-      <p:sp>
-        <p:nvSpPr>
-          <p:cNvPr id="7" name="impact1-dot"/>
+          <a:noFill/>
+        </p:spPr>
+        <p:txBody>
+          <a:bodyPr wrap="square" lIns="0" rIns="0" tIns="0" bIns="0" anchor="t">
+            <a:spAutoFit/>
+          </a:bodyPr>
+          <a:lstStyle/>
+          <a:p>
+            <a:pPr algn="l"/>
+            <a:r>
+              <a:rPr sz="1800" b="1" i="0">
+                <a:solidFill>
+                  <a:srgbClr val="1B2430"/>
+                </a:solidFill>
+                <a:latin typeface="Calibri"/>
+              </a:rPr>
+              <a:t>Risk managers</a:t>
+            </a:r>
+          </a:p>
+        </p:txBody>
+      </p:sp>
+      <p:sp>
+        <p:nvSpPr>
+          <p:cNvPr id="7" name="text"/>
+          <p:cNvSpPr txBox="1"/>
+          <p:nvPr/>
+        </p:nvSpPr>
+        <p:spPr>
+          <a:xfrm>
+            <a:off x="1051560" y="2057400"/>
+            <a:ext cx="3154680" cy="1188720"/>
+          </a:xfrm>
+          <a:prstGeom prst="rect">
+            <a:avLst/>
+          </a:prstGeom>
+          <a:noFill/>
+        </p:spPr>
+        <p:txBody>
+          <a:bodyPr wrap="square" lIns="0" rIns="0" tIns="0" bIns="0" anchor="t">
+            <a:spAutoFit/>
+          </a:bodyPr>
+          <a:lstStyle/>
+          <a:p>
+            <a:pPr algn="l"/>
+            <a:r>
+              <a:rPr sz="1350" b="0" i="0">
+                <a:solidFill>
+                  <a:srgbClr val="5B6573"/>
+                </a:solidFill>
+                <a:latin typeface="Calibri"/>
+              </a:rPr>
+              <a:t>The right stress test runs when an adverse event is reported (not on commentary), with CET1 headroom and the positions that drive the loss</a:t>
+            </a:r>
+          </a:p>
+        </p:txBody>
+      </p:sp>
+      <p:sp>
+        <p:nvSpPr>
+          <p:cNvPr id="8" name="impact2-dot"/>
           <p:cNvSpPr/>
           <p:nvPr/>
         </p:nvSpPr>
         <p:spPr>
           <a:xfrm>
-            <a:off x="548640" y="1737360"/>
-            <a:ext cx="384048" cy="384048"/>
+            <a:off x="4343400" y="1645920"/>
+            <a:ext cx="347472" cy="347472"/>
           </a:xfrm>
           <a:prstGeom prst="ellipse">
             <a:avLst/>
           </a:prstGeom>
           <a:solidFill>
-            <a:srgbClr val="E34948"/>
+            <a:srgbClr val="2A78D6"/>
           </a:solidFill>
           <a:ln>
             <a:noFill/>
@@ -6978,14 +7044,14 @@
       </p:sp>
       <p:sp>
         <p:nvSpPr>
-          <p:cNvPr id="8" name="text"/>
+          <p:cNvPr id="9" name="text"/>
           <p:cNvSpPr txBox="1"/>
           <p:nvPr/>
         </p:nvSpPr>
         <p:spPr>
           <a:xfrm>
-            <a:off x="1143000" y="1691640"/>
-            <a:ext cx="4480560" cy="411480"/>
+            <a:off x="4846320" y="1627632"/>
+            <a:ext cx="3108960" cy="411480"/>
           </a:xfrm>
           <a:prstGeom prst="rect">
             <a:avLst/>
@@ -7000,27 +7066,27 @@
           <a:p>
             <a:pPr algn="l"/>
             <a:r>
-              <a:rPr sz="1900" b="1" i="0">
+              <a:rPr sz="1800" b="1" i="0">
                 <a:solidFill>
                   <a:srgbClr val="1B2430"/>
                 </a:solidFill>
                 <a:latin typeface="Calibri"/>
               </a:rPr>
-              <a:t>Risk managers</a:t>
-            </a:r>
-          </a:p>
-        </p:txBody>
-      </p:sp>
-      <p:sp>
-        <p:nvSpPr>
-          <p:cNvPr id="9" name="text"/>
+              <a:t>Portfolio managers</a:t>
+            </a:r>
+          </a:p>
+        </p:txBody>
+      </p:sp>
+      <p:sp>
+        <p:nvSpPr>
+          <p:cNvPr id="10" name="text"/>
           <p:cNvSpPr txBox="1"/>
           <p:nvPr/>
         </p:nvSpPr>
         <p:spPr>
           <a:xfrm>
-            <a:off x="1143000" y="2148840"/>
-            <a:ext cx="4526280" cy="868680"/>
+            <a:off x="4846320" y="2057400"/>
+            <a:ext cx="3154680" cy="1188720"/>
           </a:xfrm>
           <a:prstGeom prst="rect">
             <a:avLst/>
@@ -7035,33 +7101,33 @@
           <a:p>
             <a:pPr algn="l"/>
             <a:r>
-              <a:rPr sz="1500" b="0" i="0">
+              <a:rPr sz="1350" b="0" i="0">
                 <a:solidFill>
                   <a:srgbClr val="5B6573"/>
                 </a:solidFill>
                 <a:latin typeface="Calibri"/>
               </a:rPr>
-              <a:t>The right stress test runs when an adverse event is reported (not on commentary), with CET1 headroom and the positions that drive the loss</a:t>
-            </a:r>
-          </a:p>
-        </p:txBody>
-      </p:sp>
-      <p:sp>
-        <p:nvSpPr>
-          <p:cNvPr id="10" name="impact2-dot"/>
+              <a:t>Index tilts react to company news within limits, every change linked to its headline</a:t>
+            </a:r>
+          </a:p>
+        </p:txBody>
+      </p:sp>
+      <p:sp>
+        <p:nvSpPr>
+          <p:cNvPr id="11" name="impact3-dot"/>
           <p:cNvSpPr/>
           <p:nvPr/>
         </p:nvSpPr>
         <p:spPr>
           <a:xfrm>
-            <a:off x="548640" y="3200400"/>
-            <a:ext cx="384048" cy="384048"/>
+            <a:off x="8138160" y="1645920"/>
+            <a:ext cx="347472" cy="347472"/>
           </a:xfrm>
           <a:prstGeom prst="ellipse">
             <a:avLst/>
           </a:prstGeom>
           <a:solidFill>
-            <a:srgbClr val="2A78D6"/>
+            <a:srgbClr val="4A3AA7"/>
           </a:solidFill>
           <a:ln>
             <a:noFill/>
@@ -7091,14 +7157,14 @@
       </p:sp>
       <p:sp>
         <p:nvSpPr>
-          <p:cNvPr id="11" name="text"/>
+          <p:cNvPr id="12" name="text"/>
           <p:cNvSpPr txBox="1"/>
           <p:nvPr/>
         </p:nvSpPr>
         <p:spPr>
           <a:xfrm>
-            <a:off x="1143000" y="3154680"/>
-            <a:ext cx="4480560" cy="411480"/>
+            <a:off x="8641080" y="1627632"/>
+            <a:ext cx="3108960" cy="411480"/>
           </a:xfrm>
           <a:prstGeom prst="rect">
             <a:avLst/>
@@ -7113,27 +7179,27 @@
           <a:p>
             <a:pPr algn="l"/>
             <a:r>
-              <a:rPr sz="1900" b="1" i="0">
+              <a:rPr sz="1800" b="1" i="0">
                 <a:solidFill>
                   <a:srgbClr val="1B2430"/>
                 </a:solidFill>
                 <a:latin typeface="Calibri"/>
               </a:rPr>
-              <a:t>Portfolio managers</a:t>
-            </a:r>
-          </a:p>
-        </p:txBody>
-      </p:sp>
-      <p:sp>
-        <p:nvSpPr>
-          <p:cNvPr id="12" name="text"/>
+              <a:t>Model risk &amp; audit</a:t>
+            </a:r>
+          </a:p>
+        </p:txBody>
+      </p:sp>
+      <p:sp>
+        <p:nvSpPr>
+          <p:cNvPr id="13" name="text"/>
           <p:cNvSpPr txBox="1"/>
           <p:nvPr/>
         </p:nvSpPr>
         <p:spPr>
           <a:xfrm>
-            <a:off x="1143000" y="3611880"/>
-            <a:ext cx="4526280" cy="868680"/>
+            <a:off x="8641080" y="2057400"/>
+            <a:ext cx="3154680" cy="1188720"/>
           </a:xfrm>
           <a:prstGeom prst="rect">
             <a:avLst/>
@@ -7148,37 +7214,42 @@
           <a:p>
             <a:pPr algn="l"/>
             <a:r>
-              <a:rPr sz="1500" b="0" i="0">
+              <a:rPr sz="1350" b="0" i="0">
                 <a:solidFill>
                   <a:srgbClr val="5B6573"/>
                 </a:solidFill>
                 <a:latin typeface="Calibri"/>
               </a:rPr>
-              <a:t>Index tilts react to company news within limits, every change linked to its headline</a:t>
-            </a:r>
-          </a:p>
-        </p:txBody>
-      </p:sp>
-      <p:sp>
-        <p:nvSpPr>
-          <p:cNvPr id="13" name="impact3-dot"/>
+              <a:t>Every score carries its drivers, schema and model version; results are reproducible from the repo</a:t>
+            </a:r>
+          </a:p>
+        </p:txBody>
+      </p:sp>
+      <p:sp>
+        <p:nvSpPr>
+          <p:cNvPr id="14" name="screenshot-frame"/>
           <p:cNvSpPr/>
           <p:nvPr/>
         </p:nvSpPr>
         <p:spPr>
           <a:xfrm>
-            <a:off x="548640" y="4663440"/>
-            <a:ext cx="384048" cy="384048"/>
-          </a:xfrm>
-          <a:prstGeom prst="ellipse">
-            <a:avLst/>
+            <a:off x="1384237" y="3291840"/>
+            <a:ext cx="9423220" cy="2734056"/>
+          </a:xfrm>
+          <a:prstGeom prst="roundRect">
+            <a:avLst>
+              <a:gd name="adj" fmla="val 6000"/>
+            </a:avLst>
           </a:prstGeom>
           <a:solidFill>
-            <a:srgbClr val="4A3AA7"/>
+            <a:srgbClr val="F3F6FA"/>
           </a:solidFill>
-          <a:ln>
-            <a:noFill/>
+          <a:ln w="12700">
+            <a:solidFill>
+              <a:srgbClr val="D5DBE3"/>
+            </a:solidFill>
           </a:ln>
+          <a:effectLst/>
         </p:spPr>
         <p:style>
           <a:lnRef idx="1">
@@ -7202,16 +7273,40 @@
           </a:p>
         </p:txBody>
       </p:sp>
-      <p:sp>
-        <p:nvSpPr>
-          <p:cNvPr id="14" name="text"/>
+      <p:pic>
+        <p:nvPicPr>
+          <p:cNvPr id="15" name="dashboard-module-b" descr="dashboard_module_B_strip.png"/>
+          <p:cNvPicPr>
+            <a:picLocks noChangeAspect="1"/>
+          </p:cNvPicPr>
+          <p:nvPr/>
+        </p:nvPicPr>
+        <p:blipFill>
+          <a:blip r:embed="rId2"/>
+          <a:stretch>
+            <a:fillRect/>
+          </a:stretch>
+        </p:blipFill>
+        <p:spPr>
+          <a:xfrm>
+            <a:off x="1493965" y="3401568"/>
+            <a:ext cx="9203765" cy="2514600"/>
+          </a:xfrm>
+          <a:prstGeom prst="rect">
+            <a:avLst/>
+          </a:prstGeom>
+        </p:spPr>
+      </p:pic>
+      <p:sp>
+        <p:nvSpPr>
+          <p:cNvPr id="16" name="text"/>
           <p:cNvSpPr txBox="1"/>
           <p:nvPr/>
         </p:nvSpPr>
         <p:spPr>
           <a:xfrm>
-            <a:off x="1143000" y="4617720"/>
-            <a:ext cx="4480560" cy="411480"/>
+            <a:off x="1493965" y="6117336"/>
+            <a:ext cx="9203764" cy="274320"/>
           </a:xfrm>
           <a:prstGeom prst="rect">
             <a:avLst/>
@@ -7226,48 +7321,13 @@
           <a:p>
             <a:pPr algn="l"/>
             <a:r>
-              <a:rPr sz="1900" b="1" i="0">
-                <a:solidFill>
-                  <a:srgbClr val="1B2430"/>
-                </a:solidFill>
-                <a:latin typeface="Calibri"/>
-              </a:rPr>
-              <a:t>Model risk &amp; audit</a:t>
-            </a:r>
-          </a:p>
-        </p:txBody>
-      </p:sp>
-      <p:sp>
-        <p:nvSpPr>
-          <p:cNvPr id="15" name="text"/>
-          <p:cNvSpPr txBox="1"/>
-          <p:nvPr/>
-        </p:nvSpPr>
-        <p:spPr>
-          <a:xfrm>
-            <a:off x="1143000" y="5074920"/>
-            <a:ext cx="4526280" cy="868680"/>
-          </a:xfrm>
-          <a:prstGeom prst="rect">
-            <a:avLst/>
-          </a:prstGeom>
-          <a:noFill/>
-        </p:spPr>
-        <p:txBody>
-          <a:bodyPr wrap="square" lIns="0" rIns="0" tIns="0" bIns="0" anchor="t">
-            <a:spAutoFit/>
-          </a:bodyPr>
-          <a:lstStyle/>
-          <a:p>
-            <a:pPr algn="l"/>
-            <a:r>
-              <a:rPr sz="1500" b="0" i="0">
+              <a:rPr sz="1200" b="0" i="1">
                 <a:solidFill>
                   <a:srgbClr val="5B6573"/>
                 </a:solidFill>
                 <a:latin typeface="Calibri"/>
               </a:rPr>
-              <a:t>Every score carries its drivers, schema and model version; results are reproducible from the repo</a:t>
+              <a:t>Module B in the dashboard: the triggering headline, the scenario applied, value before and after, and the capital check</a:t>
             </a:r>
           </a:p>
         </p:txBody>
@@ -7501,7 +7561,7 @@
                 </a:solidFill>
                 <a:latin typeface="Calibri"/>
               </a:rPr>
-              <a:t>Story clusters swallowed unrelated news: now anchored on the first report</a:t>
+              <a:t>The stress trigger ran on 90% of trading days: added a red-alert tier, tested out of sample</a:t>
             </a:r>
           </a:p>
         </p:txBody>

</xml_diff>